<commit_message>
Refresh pitch-deck screenshots from the live Oppuna app.
Replace outdated Play Store creatives with current in-app captures
for home, plan, mood, journal, and chat.

Co-authored-by: Kaushik B Itagi <kaushikitagib@yahoo.com>
</commit_message>
<xml_diff>
--- a/site/investor/Oppuna-Investor-Pitch-Deck.pptx
+++ b/site/investor/Oppuna-Investor-Pitch-Deck.pptx
@@ -526,7 +526,7 @@
 SOURCES
 - https://oppuna.com
 - Google Play: https://play.google.com/store/apps/details?id=com.oppuna.care
-- Cover screenshot: official Google Play listing creative, Aug 2026.</a:t>
+- Cover screenshot: captured from the current Oppuna application UI (running build), Aug 2026.</a:t>
             </a:r>
           </a:p>
         </p:txBody>
@@ -1567,10 +1567,9 @@
           <a:p>
             <a:r>
               <a:t>SPEAKER (~40s)
-Walk the realistic journey with only verified screenshots from the Google Play listing. Full journey in words: mood check-in → structured exercise or daily plan → journal / thought record / breathe / ground / talk → small next action → return to observe patterns.
-Only three official listing screenshots were available; steps match those assets rather than fabricating screens.
+Walk the realistic journey with current in-app screenshots: mood check-in → daily plan → journal / thought record → talk with companion → return home to observe patterns.
 SOURCES
-- Screenshots: Google Play listing creatives for com.oppuna.care, Aug 2026
+- Screenshots: captured from the current Oppuna application UI (running build), Aug 2026
 - Journey capabilities: https://oppuna.com</a:t>
             </a:r>
           </a:p>
@@ -5139,7 +5138,7 @@
       </p:sp>
       <p:pic>
         <p:nvPicPr>
-          <p:cNvPr id="11" name="Picture 10" descr="screen_02_clean.jpg"/>
+          <p:cNvPr id="11" name="Picture 10" descr="app_home_phone.jpg"/>
           <p:cNvPicPr>
             <a:picLocks noChangeAspect="1"/>
           </p:cNvPicPr>
@@ -5154,7 +5153,7 @@
         <p:spPr>
           <a:xfrm>
             <a:off x="5989320" y="502920"/>
-            <a:ext cx="2238150" cy="5852160"/>
+            <a:ext cx="2779368" cy="5852160"/>
           </a:xfrm>
           <a:prstGeom prst="rect">
             <a:avLst/>
@@ -17036,23 +17035,23 @@
         </p:nvSpPr>
         <p:spPr>
           <a:xfrm>
-            <a:off x="594360" y="1371600"/>
-            <a:ext cx="3566160" cy="365760"/>
-          </a:xfrm>
-          <a:prstGeom prst="rect">
-            <a:avLst/>
-          </a:prstGeom>
-          <a:noFill/>
-        </p:spPr>
-        <p:txBody>
-          <a:bodyPr wrap="square" anchor="t">
-            <a:spAutoFit/>
-          </a:bodyPr>
-          <a:lstStyle/>
-          <a:p>
-            <a:pPr algn="l"/>
-            <a:r>
-              <a:rPr sz="1500" b="1">
+            <a:off x="594360" y="1353312"/>
+            <a:ext cx="2148840" cy="365760"/>
+          </a:xfrm>
+          <a:prstGeom prst="rect">
+            <a:avLst/>
+          </a:prstGeom>
+          <a:noFill/>
+        </p:spPr>
+        <p:txBody>
+          <a:bodyPr wrap="square" anchor="t">
+            <a:spAutoFit/>
+          </a:bodyPr>
+          <a:lstStyle/>
+          <a:p>
+            <a:pPr algn="ctr"/>
+            <a:r>
+              <a:rPr sz="1300" b="1">
                 <a:solidFill>
                   <a:srgbClr val="2F5446"/>
                 </a:solidFill>
@@ -17060,14 +17059,14 @@
                 <a:ea typeface="Outfit"/>
                 <a:cs typeface="Outfit"/>
               </a:rPr>
-              <a:t>1. Open a private space</a:t>
+              <a:t>1. Check in</a:t>
             </a:r>
           </a:p>
         </p:txBody>
       </p:sp>
       <p:pic>
         <p:nvPicPr>
-          <p:cNvPr id="5" name="Picture 4" descr="screen_00_clean.jpg"/>
+          <p:cNvPr id="5" name="Picture 4" descr="app_mood_phone.jpg"/>
           <p:cNvPicPr>
             <a:picLocks noChangeAspect="1"/>
           </p:cNvPicPr>
@@ -17081,8 +17080,8 @@
         </p:blipFill>
         <p:spPr>
           <a:xfrm>
-            <a:off x="1097280" y="1828800"/>
-            <a:ext cx="1468786" cy="3840480"/>
+            <a:off x="777240" y="1783080"/>
+            <a:ext cx="1889102" cy="3977639"/>
           </a:xfrm>
           <a:prstGeom prst="rect">
             <a:avLst/>
@@ -17097,8 +17096,8 @@
         </p:nvSpPr>
         <p:spPr>
           <a:xfrm>
-            <a:off x="594360" y="5806440"/>
-            <a:ext cx="3566160" cy="365760"/>
+            <a:off x="594360" y="5852160"/>
+            <a:ext cx="2148840" cy="320040"/>
           </a:xfrm>
           <a:prstGeom prst="rect">
             <a:avLst/>
@@ -17113,7 +17112,7 @@
           <a:p>
             <a:pPr algn="ctr"/>
             <a:r>
-              <a:rPr sz="1300" b="0">
+              <a:rPr sz="1200" b="0">
                 <a:solidFill>
                   <a:srgbClr val="5A675F"/>
                 </a:solidFill>
@@ -17121,7 +17120,7 @@
                 <a:ea typeface="Outfit"/>
                 <a:cs typeface="Outfit"/>
               </a:rPr>
-              <a:t>No account. Begin on the device.</a:t>
+              <a:t>Mood on this device</a:t>
             </a:r>
           </a:p>
         </p:txBody>
@@ -17134,23 +17133,23 @@
         </p:nvSpPr>
         <p:spPr>
           <a:xfrm>
-            <a:off x="4389120" y="1371600"/>
-            <a:ext cx="3566160" cy="365760"/>
-          </a:xfrm>
-          <a:prstGeom prst="rect">
-            <a:avLst/>
-          </a:prstGeom>
-          <a:noFill/>
-        </p:spPr>
-        <p:txBody>
-          <a:bodyPr wrap="square" anchor="t">
-            <a:spAutoFit/>
-          </a:bodyPr>
-          <a:lstStyle/>
-          <a:p>
-            <a:pPr algn="l"/>
-            <a:r>
-              <a:rPr sz="1500" b="1">
+            <a:off x="2862072" y="1353312"/>
+            <a:ext cx="2148840" cy="365760"/>
+          </a:xfrm>
+          <a:prstGeom prst="rect">
+            <a:avLst/>
+          </a:prstGeom>
+          <a:noFill/>
+        </p:spPr>
+        <p:txBody>
+          <a:bodyPr wrap="square" anchor="t">
+            <a:spAutoFit/>
+          </a:bodyPr>
+          <a:lstStyle/>
+          <a:p>
+            <a:pPr algn="ctr"/>
+            <a:r>
+              <a:rPr sz="1300" b="1">
                 <a:solidFill>
                   <a:srgbClr val="2F5446"/>
                 </a:solidFill>
@@ -17158,14 +17157,14 @@
                 <a:ea typeface="Outfit"/>
                 <a:cs typeface="Outfit"/>
               </a:rPr>
-              <a:t>2. Check in and follow today’s care</a:t>
+              <a:t>2. Daily plan</a:t>
             </a:r>
           </a:p>
         </p:txBody>
       </p:sp>
       <p:pic>
         <p:nvPicPr>
-          <p:cNvPr id="8" name="Picture 7" descr="screen_02_clean.jpg"/>
+          <p:cNvPr id="8" name="Picture 7" descr="app_plan_phone.jpg"/>
           <p:cNvPicPr>
             <a:picLocks noChangeAspect="1"/>
           </p:cNvPicPr>
@@ -17179,8 +17178,8 @@
         </p:blipFill>
         <p:spPr>
           <a:xfrm>
-            <a:off x="4892040" y="1828800"/>
-            <a:ext cx="1468786" cy="3840480"/>
+            <a:off x="3044952" y="1783080"/>
+            <a:ext cx="1889102" cy="3977639"/>
           </a:xfrm>
           <a:prstGeom prst="rect">
             <a:avLst/>
@@ -17195,8 +17194,8 @@
         </p:nvSpPr>
         <p:spPr>
           <a:xfrm>
-            <a:off x="4389120" y="5806440"/>
-            <a:ext cx="3566160" cy="365760"/>
+            <a:off x="2862072" y="5852160"/>
+            <a:ext cx="2148840" cy="320040"/>
           </a:xfrm>
           <a:prstGeom prst="rect">
             <a:avLst/>
@@ -17211,7 +17210,7 @@
           <a:p>
             <a:pPr algn="ctr"/>
             <a:r>
-              <a:rPr sz="1300" b="0">
+              <a:rPr sz="1200" b="0">
                 <a:solidFill>
                   <a:srgbClr val="5A675F"/>
                 </a:solidFill>
@@ -17219,7 +17218,7 @@
                 <a:ea typeface="Outfit"/>
                 <a:cs typeface="Outfit"/>
               </a:rPr>
-              <a:t>Mood, plan, talk, small actions.</a:t>
+              <a:t>Small structured steps</a:t>
             </a:r>
           </a:p>
         </p:txBody>
@@ -17232,23 +17231,23 @@
         </p:nvSpPr>
         <p:spPr>
           <a:xfrm>
-            <a:off x="8183880" y="1371600"/>
-            <a:ext cx="3566160" cy="365760"/>
-          </a:xfrm>
-          <a:prstGeom prst="rect">
-            <a:avLst/>
-          </a:prstGeom>
-          <a:noFill/>
-        </p:spPr>
-        <p:txBody>
-          <a:bodyPr wrap="square" anchor="t">
-            <a:spAutoFit/>
-          </a:bodyPr>
-          <a:lstStyle/>
-          <a:p>
-            <a:pPr algn="l"/>
-            <a:r>
-              <a:rPr sz="1500" b="1">
+            <a:off x="5129784" y="1353312"/>
+            <a:ext cx="2148840" cy="365760"/>
+          </a:xfrm>
+          <a:prstGeom prst="rect">
+            <a:avLst/>
+          </a:prstGeom>
+          <a:noFill/>
+        </p:spPr>
+        <p:txBody>
+          <a:bodyPr wrap="square" anchor="t">
+            <a:spAutoFit/>
+          </a:bodyPr>
+          <a:lstStyle/>
+          <a:p>
+            <a:pPr algn="ctr"/>
+            <a:r>
+              <a:rPr sz="1300" b="1">
                 <a:solidFill>
                   <a:srgbClr val="2F5446"/>
                 </a:solidFill>
@@ -17256,14 +17255,14 @@
                 <a:ea typeface="Outfit"/>
                 <a:cs typeface="Outfit"/>
               </a:rPr>
-              <a:t>3. Journal and keep it local</a:t>
+              <a:t>3. Journal</a:t>
             </a:r>
           </a:p>
         </p:txBody>
       </p:sp>
       <p:pic>
         <p:nvPicPr>
-          <p:cNvPr id="11" name="Picture 10" descr="screen_01_clean.jpg"/>
+          <p:cNvPr id="11" name="Picture 10" descr="app_journal_editor_phone.jpg"/>
           <p:cNvPicPr>
             <a:picLocks noChangeAspect="1"/>
           </p:cNvPicPr>
@@ -17277,8 +17276,8 @@
         </p:blipFill>
         <p:spPr>
           <a:xfrm>
-            <a:off x="8686800" y="1828800"/>
-            <a:ext cx="1468786" cy="3840480"/>
+            <a:off x="5312664" y="1783080"/>
+            <a:ext cx="1889102" cy="3977639"/>
           </a:xfrm>
           <a:prstGeom prst="rect">
             <a:avLst/>
@@ -17293,8 +17292,8 @@
         </p:nvSpPr>
         <p:spPr>
           <a:xfrm>
-            <a:off x="8183880" y="5806440"/>
-            <a:ext cx="3566160" cy="365760"/>
+            <a:off x="5129784" y="5852160"/>
+            <a:ext cx="2148840" cy="320040"/>
           </a:xfrm>
           <a:prstGeom prst="rect">
             <a:avLst/>
@@ -17309,7 +17308,7 @@
           <a:p>
             <a:pPr algn="ctr"/>
             <a:r>
-              <a:rPr sz="1300" b="0">
+              <a:rPr sz="1200" b="0">
                 <a:solidFill>
                   <a:srgbClr val="5A675F"/>
                 </a:solidFill>
@@ -17317,7 +17316,7 @@
                 <a:ea typeface="Outfit"/>
                 <a:cs typeface="Outfit"/>
               </a:rPr>
-              <a:t>Thoughts stay on this device.</a:t>
+              <a:t>Thoughts stay local</a:t>
             </a:r>
           </a:p>
         </p:txBody>
@@ -17325,6 +17324,202 @@
       <p:sp>
         <p:nvSpPr>
           <p:cNvPr id="13" name="TextBox 12"/>
+          <p:cNvSpPr txBox="1"/>
+          <p:nvPr/>
+        </p:nvSpPr>
+        <p:spPr>
+          <a:xfrm>
+            <a:off x="7397496" y="1353312"/>
+            <a:ext cx="2148840" cy="365760"/>
+          </a:xfrm>
+          <a:prstGeom prst="rect">
+            <a:avLst/>
+          </a:prstGeom>
+          <a:noFill/>
+        </p:spPr>
+        <p:txBody>
+          <a:bodyPr wrap="square" anchor="t">
+            <a:spAutoFit/>
+          </a:bodyPr>
+          <a:lstStyle/>
+          <a:p>
+            <a:pPr algn="ctr"/>
+            <a:r>
+              <a:rPr sz="1300" b="1">
+                <a:solidFill>
+                  <a:srgbClr val="2F5446"/>
+                </a:solidFill>
+                <a:latin typeface="Outfit"/>
+                <a:ea typeface="Outfit"/>
+                <a:cs typeface="Outfit"/>
+              </a:rPr>
+              <a:t>4. Talk</a:t>
+            </a:r>
+          </a:p>
+        </p:txBody>
+      </p:sp>
+      <p:pic>
+        <p:nvPicPr>
+          <p:cNvPr id="14" name="Picture 13" descr="app_chat_phone.jpg"/>
+          <p:cNvPicPr>
+            <a:picLocks noChangeAspect="1"/>
+          </p:cNvPicPr>
+          <p:nvPr/>
+        </p:nvPicPr>
+        <p:blipFill>
+          <a:blip r:embed="rId5"/>
+          <a:stretch>
+            <a:fillRect/>
+          </a:stretch>
+        </p:blipFill>
+        <p:spPr>
+          <a:xfrm>
+            <a:off x="7580376" y="1783080"/>
+            <a:ext cx="1889102" cy="3977639"/>
+          </a:xfrm>
+          <a:prstGeom prst="rect">
+            <a:avLst/>
+          </a:prstGeom>
+        </p:spPr>
+      </p:pic>
+      <p:sp>
+        <p:nvSpPr>
+          <p:cNvPr id="15" name="TextBox 14"/>
+          <p:cNvSpPr txBox="1"/>
+          <p:nvPr/>
+        </p:nvSpPr>
+        <p:spPr>
+          <a:xfrm>
+            <a:off x="7397496" y="5852160"/>
+            <a:ext cx="2148840" cy="320040"/>
+          </a:xfrm>
+          <a:prstGeom prst="rect">
+            <a:avLst/>
+          </a:prstGeom>
+          <a:noFill/>
+        </p:spPr>
+        <p:txBody>
+          <a:bodyPr wrap="square" anchor="t">
+            <a:spAutoFit/>
+          </a:bodyPr>
+          <a:lstStyle/>
+          <a:p>
+            <a:pPr algn="ctr"/>
+            <a:r>
+              <a:rPr sz="1200" b="0">
+                <a:solidFill>
+                  <a:srgbClr val="5A675F"/>
+                </a:solidFill>
+                <a:latin typeface="Outfit"/>
+                <a:ea typeface="Outfit"/>
+                <a:cs typeface="Outfit"/>
+              </a:rPr>
+              <a:t>On-device companion</a:t>
+            </a:r>
+          </a:p>
+        </p:txBody>
+      </p:sp>
+      <p:sp>
+        <p:nvSpPr>
+          <p:cNvPr id="16" name="TextBox 15"/>
+          <p:cNvSpPr txBox="1"/>
+          <p:nvPr/>
+        </p:nvSpPr>
+        <p:spPr>
+          <a:xfrm>
+            <a:off x="9665208" y="1353312"/>
+            <a:ext cx="2148840" cy="365760"/>
+          </a:xfrm>
+          <a:prstGeom prst="rect">
+            <a:avLst/>
+          </a:prstGeom>
+          <a:noFill/>
+        </p:spPr>
+        <p:txBody>
+          <a:bodyPr wrap="square" anchor="t">
+            <a:spAutoFit/>
+          </a:bodyPr>
+          <a:lstStyle/>
+          <a:p>
+            <a:pPr algn="ctr"/>
+            <a:r>
+              <a:rPr sz="1300" b="1">
+                <a:solidFill>
+                  <a:srgbClr val="2F5446"/>
+                </a:solidFill>
+                <a:latin typeface="Outfit"/>
+                <a:ea typeface="Outfit"/>
+                <a:cs typeface="Outfit"/>
+              </a:rPr>
+              <a:t>5. Return home</a:t>
+            </a:r>
+          </a:p>
+        </p:txBody>
+      </p:sp>
+      <p:pic>
+        <p:nvPicPr>
+          <p:cNvPr id="17" name="Picture 16" descr="app_home_phone.jpg"/>
+          <p:cNvPicPr>
+            <a:picLocks noChangeAspect="1"/>
+          </p:cNvPicPr>
+          <p:nvPr/>
+        </p:nvPicPr>
+        <p:blipFill>
+          <a:blip r:embed="rId6"/>
+          <a:stretch>
+            <a:fillRect/>
+          </a:stretch>
+        </p:blipFill>
+        <p:spPr>
+          <a:xfrm>
+            <a:off x="9848088" y="1783080"/>
+            <a:ext cx="1889102" cy="3977639"/>
+          </a:xfrm>
+          <a:prstGeom prst="rect">
+            <a:avLst/>
+          </a:prstGeom>
+        </p:spPr>
+      </p:pic>
+      <p:sp>
+        <p:nvSpPr>
+          <p:cNvPr id="18" name="TextBox 17"/>
+          <p:cNvSpPr txBox="1"/>
+          <p:nvPr/>
+        </p:nvSpPr>
+        <p:spPr>
+          <a:xfrm>
+            <a:off x="9665208" y="5852160"/>
+            <a:ext cx="2148840" cy="320040"/>
+          </a:xfrm>
+          <a:prstGeom prst="rect">
+            <a:avLst/>
+          </a:prstGeom>
+          <a:noFill/>
+        </p:spPr>
+        <p:txBody>
+          <a:bodyPr wrap="square" anchor="t">
+            <a:spAutoFit/>
+          </a:bodyPr>
+          <a:lstStyle/>
+          <a:p>
+            <a:pPr algn="ctr"/>
+            <a:r>
+              <a:rPr sz="1200" b="0">
+                <a:solidFill>
+                  <a:srgbClr val="5A675F"/>
+                </a:solidFill>
+                <a:latin typeface="Outfit"/>
+                <a:ea typeface="Outfit"/>
+                <a:cs typeface="Outfit"/>
+              </a:rPr>
+              <a:t>Observe patterns</a:t>
+            </a:r>
+          </a:p>
+        </p:txBody>
+      </p:sp>
+      <p:sp>
+        <p:nvSpPr>
+          <p:cNvPr id="19" name="TextBox 18"/>
           <p:cNvSpPr txBox="1"/>
           <p:nvPr/>
         </p:nvSpPr>
@@ -17361,7 +17556,7 @@
       </p:sp>
       <p:sp>
         <p:nvSpPr>
-          <p:cNvPr id="14" name="TextBox 13"/>
+          <p:cNvPr id="20" name="TextBox 19"/>
           <p:cNvSpPr txBox="1"/>
           <p:nvPr/>
         </p:nvSpPr>

</xml_diff>

<commit_message>
Remove company legal name from investor deck materials.
Drop ADILAKSHMI INFOTECH PRIVATE LIMITED from the cover slide,
landing page, and PDF metadata.

Co-authored-by: Kaushik B Itagi <kaushikitagib@yahoo.com>
</commit_message>
<xml_diff>
--- a/site/investor/Oppuna-Investor-Pitch-Deck.pptx
+++ b/site/investor/Oppuna-Investor-Pitch-Deck.pptx
@@ -5099,46 +5099,9 @@
           </a:p>
         </p:txBody>
       </p:sp>
-      <p:sp>
-        <p:nvSpPr>
-          <p:cNvPr id="10" name="TextBox 9"/>
-          <p:cNvSpPr txBox="1"/>
-          <p:nvPr/>
-        </p:nvSpPr>
-        <p:spPr>
-          <a:xfrm>
-            <a:off x="685800" y="6263640"/>
-            <a:ext cx="3840480" cy="320040"/>
-          </a:xfrm>
-          <a:prstGeom prst="rect">
-            <a:avLst/>
-          </a:prstGeom>
-          <a:noFill/>
-        </p:spPr>
-        <p:txBody>
-          <a:bodyPr wrap="square" anchor="t">
-            <a:spAutoFit/>
-          </a:bodyPr>
-          <a:lstStyle/>
-          <a:p>
-            <a:pPr algn="l"/>
-            <a:r>
-              <a:rPr sz="1000" b="0">
-                <a:solidFill>
-                  <a:srgbClr val="DCE8E2"/>
-                </a:solidFill>
-                <a:latin typeface="Outfit"/>
-                <a:ea typeface="Outfit"/>
-                <a:cs typeface="Outfit"/>
-              </a:rPr>
-              <a:t>ADILAKSHMI INFOTECH PRIVATE LIMITED</a:t>
-            </a:r>
-          </a:p>
-        </p:txBody>
-      </p:sp>
       <p:pic>
         <p:nvPicPr>
-          <p:cNvPr id="11" name="Picture 10" descr="app_home_phone.jpg"/>
+          <p:cNvPr id="10" name="Picture 9" descr="app_home_phone.jpg"/>
           <p:cNvPicPr>
             <a:picLocks noChangeAspect="1"/>
           </p:cNvPicPr>

</xml_diff>